<commit_message>
Update team roster across docs and regenerate submission PDFs
</commit_message>
<xml_diff>
--- a/SOURCES/KAYA-Deck.pptx
+++ b/SOURCES/KAYA-Deck.pptx
@@ -2796,8 +2796,8 @@
         </p:nvSpPr>
         <p:spPr>
           <a:xfrm>
-            <a:off x="7071055" y="5852160"/>
-            <a:ext cx="4572000" cy="365760"/>
+            <a:off x="548640" y="5852160"/>
+            <a:ext cx="11094415" cy="365760"/>
           </a:xfrm>
           <a:prstGeom prst="rect">
             <a:avLst/>
@@ -2813,7 +2813,7 @@
               <a:buNone/>
             </a:pPr>
             <a:r>
-              <a:rPr lang="en-US" sz="1200" dirty="0">
+              <a:rPr lang="en-US" sz="950" dirty="0">
                 <a:solidFill>
                   <a:srgbClr val="6B7280"/>
                 </a:solidFill>
@@ -2821,9 +2821,9 @@
                 <a:ea typeface="Segoe UI" pitchFamily="34" charset="-122"/>
                 <a:cs typeface="Segoe UI" pitchFamily="34" charset="-120"/>
               </a:rPr>
-              <a:t>Team: [your team name]</a:t>
-            </a:r>
-            <a:endParaRPr lang="en-US" sz="1200" dirty="0"/>
+              <a:t>Team KAYA · Christian Gabrielle Mariveles, Hannah Munoz, Adrian Joseph Salim, Aldrhey Jave M. Agsunod</a:t>
+            </a:r>
+            <a:endParaRPr lang="en-US" sz="950" dirty="0"/>
           </a:p>
         </p:txBody>
       </p:sp>
@@ -9225,7 +9225,7 @@
               <a:buNone/>
             </a:pPr>
             <a:r>
-              <a:rPr lang="en-US" sz="1200" dirty="0">
+              <a:rPr lang="en-US" sz="1100" dirty="0">
                 <a:solidFill>
                   <a:srgbClr val="6B7280"/>
                 </a:solidFill>
@@ -9233,9 +9233,9 @@
                 <a:ea typeface="Segoe UI" pitchFamily="34" charset="-122"/>
                 <a:cs typeface="Segoe UI" pitchFamily="34" charset="-120"/>
               </a:rPr>
-              <a:t>Team: [your team name]  ·  [email]  ·  [github / demo link]</a:t>
-            </a:r>
-            <a:endParaRPr lang="en-US" sz="1200" dirty="0"/>
+              <a:t>Team KAYA  ·  github.com/ShinkoSiVes/KAYA_apac-x-stelar_Hackathon</a:t>
+            </a:r>
+            <a:endParaRPr lang="en-US" sz="1100" dirty="0"/>
           </a:p>
         </p:txBody>
       </p:sp>

</xml_diff>